<commit_message>
feat(extension): washer X-ray, deck refresh, live-camera demo frames, no generic ACK before a question
The text demo now sends a camera frame a second, like the live sampler, so the
agent looks before asking (router story 6/6 live). The X-ray draws a write held
at the CommitGate and strikes it when it is never sent; new washer page. Deck:
extension slide, results aligned with the README. Demo profile only:
no generic acknowledgement right before a clarifying question.

Claude-Session: https://claude.ai/code/session_01NTYbYeHNX8eZTQQA8UwCCg
</commit_message>
<xml_diff>
--- a/docs/deck/Janus_Submission.pptx
+++ b/docs/deck/Janus_Submission.pptx
@@ -14086,7 +14086,7 @@
           <a:p>
             <a:r>
               <a:rPr sz="2000" b="0"/>
-              <a:t>418 deterministic tests (stepped clock, scripted model), TraceChecker on every run, adversarial explorer over 19 race scenarios.</a:t>
+              <a:t>587 deterministic tests (stepped clock, scripted model), TraceChecker on every run, adversarial explorer over 19 race scenarios.</a:t>
             </a:r>
           </a:p>
           <a:p>
@@ -14098,7 +14098,7 @@
           <a:p>
             <a:r>
               <a:rPr sz="2000" b="0"/>
-              <a:t>Limits: voice-path number is from a partial, earlier run; housing 23%; hosted model is not bit-reproducible; a write with no go-ahead stays blocked rather than asking.</a:t>
+              <a:t>Limits: the full voice run predates the turn-ending fixes; housing 35%; the hosted model is not bit-reproducible; the extension's device backend is simulated.</a:t>
             </a:r>
           </a:p>
         </p:txBody>
@@ -14174,7 +14174,7 @@
             </a:pPr>
             <a:r>
               <a:rPr sz="3000" b="1"/>
-              <a:t>Extension: camera-grounded device care</a:t>
+              <a:t>Extension: Samsung-style home care</a:t>
             </a:r>
             <a:endParaRPr b="1">
               <a:solidFill>
@@ -14194,8 +14194,8 @@
         </p:nvSpPr>
         <p:spPr>
           <a:xfrm>
-            <a:off x="822960" y="1463040"/>
-            <a:ext cx="9692640" cy="4480560"/>
+            <a:off x="7315200" y="1371600"/>
+            <a:ext cx="3566160" cy="4572000"/>
           </a:xfrm>
           <a:prstGeom prst="rect">
             <a:avLst/>
@@ -14228,37 +14228,61 @@
               <a:buNone/>
             </a:pPr>
             <a:r>
-              <a:rPr sz="2100" b="0"/>
-              <a:t>Point a phone camera at a router or washer and talk: “what does this blinking light mean?”</a:t>
+              <a:rPr sz="1400" b="0"/>
+              <a:t>Router read from the camera; a Samsung washer (codes 4C, 5C, UB, dC) through a SmartThings-shaped status.</a:t>
             </a:r>
             <a:endParaRPr/>
           </a:p>
           <a:p>
             <a:r>
-              <a:rPr sz="2100" b="0"/>
-              <a:t>Vision reads the frame (orange, INTERNET); tools give the meaning and the fix steps.</a:t>
+              <a:rPr sz="1400" b="0"/>
+              <a:t>“Stop the wash … wait, just pause it”: the pending stop is never sent; pause and the booking go through once.</a:t>
             </a:r>
           </a:p>
           <a:p>
             <a:r>
-              <a:rPr sz="2100" b="0"/>
-              <a:t>“Book a technician Thursday … no wait, Friday afternoon” → exactly one booking, for Friday.</a:t>
+              <a:rPr sz="1400" b="0"/>
+              <a:t>“Resume” while 4C shows: the washer refuses, and the agent says so.</a:t>
             </a:r>
           </a:p>
           <a:p>
             <a:r>
-              <a:rPr sz="2100" b="0"/>
-              <a:t>Same kernel, different profile: declared write tools need the user's go-ahead and wait out the settle window.</a:t>
+              <a:rPr sz="1400" b="0"/>
+              <a:t>Effect ledger per session: committed, withdrawn, refused, duplicates (0).</a:t>
             </a:r>
           </a:p>
           <a:p>
             <a:r>
-              <a:rPr sz="2100" b="0"/>
-              <a:t>Runs end to end over LiveKit in a browser (mic + camera); also audio-only via error codes.</a:t>
+              <a:rPr sz="1400" b="0"/>
+              <a:t>Real: speech, camera, Gemini, the kernel. Simulated: the device and Samsung Care services.</a:t>
             </a:r>
           </a:p>
         </p:txBody>
       </p:sp>
+      <p:pic>
+        <p:nvPicPr>
+          <p:cNvPr id="133" name="Picture 132" descr="withdraw_one_of_two_writes.png"/>
+          <p:cNvPicPr>
+            <a:picLocks noChangeAspect="1"/>
+          </p:cNvPicPr>
+          <p:nvPr/>
+        </p:nvPicPr>
+        <p:blipFill>
+          <a:blip r:embed="rId3"/>
+          <a:stretch>
+            <a:fillRect/>
+          </a:stretch>
+        </p:blipFill>
+        <p:spPr>
+          <a:xfrm>
+            <a:off x="457200" y="1371600"/>
+            <a:ext cx="6675120" cy="4227576"/>
+          </a:xfrm>
+          <a:prstGeom prst="rect">
+            <a:avLst/>
+          </a:prstGeom>
+        </p:spPr>
+      </p:pic>
     </p:spTree>
   </p:cSld>
   <p:clrMapOvr>
@@ -14385,14 +14409,14 @@
             </a:pPr>
             <a:r>
               <a:rPr sz="1400" b="0"/>
-              <a:t>Text replay feeds ground-truth transcripts: it measures the reasoning and safety core, not speech or latency. Voice row: 26 of 100 recordings, earlier build.</a:t>
+              <a:t>Text replay feeds ground-truth transcripts: it measures the reasoning and safety core, not speech or latency. Voice row: all 100 recordings on 30 Sep, before the turn-ending fixes (26 re-run on 2 Oct: 16 pass, was 12).</a:t>
             </a:r>
             <a:endParaRPr/>
           </a:p>
           <a:p>
             <a:r>
               <a:rPr sz="1400" b="0"/>
-              <a:t>Housing is weakest (23%), as for every published system. The organizers' re-run of ./reproduce.sh is what scores.</a:t>
+              <a:t>Housing is weakest (35% text), as for every published system. The organizers' re-run of ./reproduce.sh is what scores.</a:t>
             </a:r>
           </a:p>
         </p:txBody>
@@ -14510,7 +14534,7 @@
                     <a:p>
                       <a:r>
                         <a:rPr sz="1300" b="1"/>
-                        <a:t>73.0%</a:t>
+                        <a:t>77.0%</a:t>
                       </a:r>
                     </a:p>
                   </a:txBody>
@@ -14523,7 +14547,7 @@
                     <a:p>
                       <a:r>
                         <a:rPr sz="1300" b="1"/>
-                        <a:t>0.953</a:t>
+                        <a:t>0.959</a:t>
                       </a:r>
                     </a:p>
                   </a:txBody>
@@ -14536,7 +14560,7 @@
                     <a:p>
                       <a:r>
                         <a:rPr sz="1300" b="1"/>
-                        <a:t>0.760</a:t>
+                        <a:t>0.807</a:t>
                       </a:r>
                     </a:p>
                   </a:txBody>
@@ -14549,7 +14573,7 @@
                     <a:p>
                       <a:r>
                         <a:rPr sz="1300" b="1"/>
-                        <a:t>0.830</a:t>
+                        <a:t>0.840</a:t>
                       </a:r>
                     </a:p>
                   </a:txBody>
@@ -14564,7 +14588,7 @@
                     <a:p>
                       <a:r>
                         <a:rPr sz="1300" b="0"/>
-                        <a:t>Janus, voice over LiveKit (sample)</a:t>
+                        <a:t>Janus, voice over LiveKit, 100 (30 Sep)</a:t>
                       </a:r>
                     </a:p>
                   </a:txBody>
@@ -14577,7 +14601,7 @@
                     <a:p>
                       <a:r>
                         <a:rPr sz="1300" b="0"/>
-                        <a:t>57.7%</a:t>
+                        <a:t>42.0%</a:t>
                       </a:r>
                     </a:p>
                   </a:txBody>
@@ -14590,7 +14614,7 @@
                     <a:p>
                       <a:r>
                         <a:rPr sz="1300" b="0"/>
-                        <a:t>0.97</a:t>
+                        <a:t>0.844</a:t>
                       </a:r>
                     </a:p>
                   </a:txBody>
@@ -14603,7 +14627,7 @@
                     <a:p>
                       <a:r>
                         <a:rPr sz="1300" b="0"/>
-                        <a:t>0.68</a:t>
+                        <a:t>0.611</a:t>
                       </a:r>
                     </a:p>
                   </a:txBody>
@@ -14616,7 +14640,7 @@
                     <a:p>
                       <a:r>
                         <a:rPr sz="1300" b="0"/>
-                        <a:t>n/a</a:t>
+                        <a:t>0.597</a:t>
                       </a:r>
                     </a:p>
                   </a:txBody>
@@ -14954,7 +14978,7 @@
             </a:pPr>
             <a:r>
               <a:rPr sz="2100" b="0"/>
-              <a:t>Ask “shall I go ahead?” instead of waiting when a write lacks the user's go-ahead.</a:t>
+              <a:t>A live SmartThings adapter behind the same tool manifest (the demo's device backend is simulated).</a:t>
             </a:r>
             <a:endParaRPr/>
           </a:p>

</xml_diff>

<commit_message>
docs(deck): note the benchmark-label disagreements on the results slide
Known Limits on the submitted deck (slide 6): 17 of the 26 voice misses
are labels that disagree with the published tools or the recording; Janus
follows the tool contract (README: Benchmark labels). Rendered and checked:
the box still fits. build_deck.py's results note and stale limits line
(it still said the full voice run predated the turn-ending fixes) updated
to match; docs/deck rebuilt.

Claude-Session: https://claude.ai/code/session_01NTYbYeHNX8eZTQQA8UwCCg
</commit_message>
<xml_diff>
--- a/docs/deck/Janus_Submission.pptx
+++ b/docs/deck/Janus_Submission.pptx
@@ -14098,7 +14098,7 @@
           <a:p>
             <a:r>
               <a:rPr sz="2000" b="0"/>
-              <a:t>Limits: the full voice run predates the turn-ending fixes; housing 35%; the hosted model is not bit-reproducible; the extension's device backend is simulated.</a:t>
+              <a:t>Limits: Janus follows the published tool contract, not labels that disagree with it (e.g. an undeclared pets_allowed); housing 35%; the hosted model is not bit-reproducible; the extension's device backend is simulated.</a:t>
             </a:r>
           </a:p>
         </p:txBody>
@@ -14416,7 +14416,7 @@
           <a:p>
             <a:r>
               <a:rPr sz="1400" b="0"/>
-              <a:t>Housing is weakest (35% text), as for every published system. The organizers' re-run of ./reproduce.sh is what scores.</a:t>
+              <a:t>Housing is weakest (35% text), as for every published system; 17 of the 26 voice misses are labels that disagree with the published tools or the recording (README: Benchmark labels). The organizers' re-run of ./reproduce.sh is what scores.</a:t>
             </a:r>
           </a:p>
         </p:txBody>

</xml_diff>

<commit_message>
docs(readme): new README built from the team's draft, corrected and extended
Structure and diagrams from the team's draft (header table, how-it-works
flowchart, self-correction sequence, CommitGate state diagram, step
diagram, setup flowchart) combined with the earlier README. Text corrected
against the code and the runs: the real G1-G11 gate table, bounded read
retries and no write retries in the benchmark profile, the 1 s settle
window of that profile, hosted speech-to-text, per-action compiled plans,
645 tests, the 4 Oct runs, the Docker run on a clean VM, the Blackwell GPU
limit, and the label disagreements. New sections: "What is inside" (the
full feature list, optional ones marked) and the Why/Deep dive parts.
Diagrams still to fix are marked with comments for the person editing
them. Test count 645 in CLAUDE.md, the build script and the generated deck.

Claude-Session: https://claude.ai/code/session_01NTYbYeHNX8eZTQQA8UwCCg
</commit_message>
<xml_diff>
--- a/docs/deck/Janus_Submission.pptx
+++ b/docs/deck/Janus_Submission.pptx
@@ -12895,7 +12895,7 @@
 </p:sld>
 </file>
 
-<file path=ppt/slides/slide4.xml><?xml version="1.0" encoding="utf-8"?>
+<file path=ppt/slides/slide3.xml><?xml version="1.0" encoding="utf-8"?>
 <p:sld xmlns:a="http://schemas.openxmlformats.org/drawingml/2006/main" xmlns:r="http://schemas.openxmlformats.org/officeDocument/2006/relationships" xmlns:mc="http://schemas.openxmlformats.org/markup-compatibility/2006" xmlns:mv="urn:schemas-microsoft-com:mac:vml" xmlns:p="http://schemas.openxmlformats.org/presentationml/2006/main" xmlns:c="http://schemas.openxmlformats.org/drawingml/2006/chart" xmlns:dgm="http://schemas.openxmlformats.org/drawingml/2006/diagram" xmlns:o="urn:schemas-microsoft-com:office:office" xmlns:v="urn:schemas-microsoft-com:vml" xmlns:pvml="urn:schemas-microsoft-com:office:powerpoint" xmlns:com="http://schemas.openxmlformats.org/drawingml/2006/compatibility" xmlns:p14="http://schemas.microsoft.com/office/powerpoint/2010/main" xmlns:p15="http://schemas.microsoft.com/office/powerpoint/2012/main" xmlns:ahyp="http://schemas.microsoft.com/office/drawing/2018/hyperlinkcolor">
   <p:cSld>
     <p:bg>
@@ -13797,7 +13797,7 @@
 </p:sld>
 </file>
 
-<file path=ppt/slides/slide5.xml><?xml version="1.0" encoding="utf-8"?>
+<file path=ppt/slides/slide4.xml><?xml version="1.0" encoding="utf-8"?>
 <p:sld xmlns:a="http://schemas.openxmlformats.org/drawingml/2006/main" xmlns:r="http://schemas.openxmlformats.org/officeDocument/2006/relationships" xmlns:mc="http://schemas.openxmlformats.org/markup-compatibility/2006" xmlns:mv="urn:schemas-microsoft-com:mac:vml" xmlns:p="http://schemas.openxmlformats.org/presentationml/2006/main" xmlns:c="http://schemas.openxmlformats.org/drawingml/2006/chart" xmlns:dgm="http://schemas.openxmlformats.org/drawingml/2006/diagram" xmlns:o="urn:schemas-microsoft-com:office:office" xmlns:v="urn:schemas-microsoft-com:vml" xmlns:pvml="urn:schemas-microsoft-com:office:powerpoint" xmlns:com="http://schemas.openxmlformats.org/drawingml/2006/compatibility" xmlns:p14="http://schemas.microsoft.com/office/powerpoint/2010/main" xmlns:p15="http://schemas.microsoft.com/office/powerpoint/2012/main" xmlns:ahyp="http://schemas.microsoft.com/office/drawing/2018/hyperlinkcolor">
   <p:cSld>
     <p:spTree>
@@ -13961,337 +13961,7 @@
 </p:sld>
 </file>
 
-<file path=ppt/slides/slide6.xml><?xml version="1.0" encoding="utf-8"?>
-<p:sld xmlns:a="http://schemas.openxmlformats.org/drawingml/2006/main" xmlns:r="http://schemas.openxmlformats.org/officeDocument/2006/relationships" xmlns:mc="http://schemas.openxmlformats.org/markup-compatibility/2006" xmlns:mv="urn:schemas-microsoft-com:mac:vml" xmlns:p="http://schemas.openxmlformats.org/presentationml/2006/main" xmlns:c="http://schemas.openxmlformats.org/drawingml/2006/chart" xmlns:dgm="http://schemas.openxmlformats.org/drawingml/2006/diagram" xmlns:o="urn:schemas-microsoft-com:office:office" xmlns:v="urn:schemas-microsoft-com:vml" xmlns:pvml="urn:schemas-microsoft-com:office:powerpoint" xmlns:com="http://schemas.openxmlformats.org/drawingml/2006/compatibility" xmlns:p14="http://schemas.microsoft.com/office/powerpoint/2010/main" xmlns:p15="http://schemas.microsoft.com/office/powerpoint/2012/main" xmlns:ahyp="http://schemas.microsoft.com/office/drawing/2018/hyperlinkcolor">
-  <p:cSld>
-    <p:spTree>
-      <p:nvGrpSpPr>
-        <p:cNvPr id="124" name="Shape 124"/>
-        <p:cNvGrpSpPr/>
-        <p:nvPr/>
-      </p:nvGrpSpPr>
-      <p:grpSpPr>
-        <a:xfrm>
-          <a:off x="0" y="0"/>
-          <a:ext cx="0" cy="0"/>
-          <a:chOff x="0" y="0"/>
-          <a:chExt cx="0" cy="0"/>
-        </a:xfrm>
-      </p:grpSpPr>
-      <p:sp>
-        <p:nvSpPr>
-          <p:cNvPr id="125" name="Google Shape;125;p6"/>
-          <p:cNvSpPr txBox="1"/>
-          <p:nvPr>
-            <p:ph type="title"/>
-          </p:nvPr>
-        </p:nvSpPr>
-        <p:spPr>
-          <a:xfrm>
-            <a:off x="838200" y="320040"/>
-            <a:ext cx="10515600" cy="914400"/>
-          </a:xfrm>
-          <a:prstGeom prst="rect">
-            <a:avLst/>
-          </a:prstGeom>
-          <a:noFill/>
-          <a:ln>
-            <a:noFill/>
-          </a:ln>
-        </p:spPr>
-        <p:txBody>
-          <a:bodyPr anchorCtr="0" anchor="ctr" bIns="45700" lIns="91425" spcFirstLastPara="1" rIns="91425" wrap="square" tIns="45700">
-            <a:normAutofit/>
-          </a:bodyPr>
-          <a:lstStyle/>
-          <a:p>
-            <a:pPr indent="0" lvl="0" marL="0" rtl="0" algn="l">
-              <a:lnSpc>
-                <a:spcPct val="90000"/>
-              </a:lnSpc>
-              <a:spcBef>
-                <a:spcPts val="0"/>
-              </a:spcBef>
-              <a:spcAft>
-                <a:spcPts val="0"/>
-              </a:spcAft>
-              <a:buClr>
-                <a:srgbClr val="704EA6"/>
-              </a:buClr>
-              <a:buSzPts val="4400"/>
-              <a:buFont typeface="Calibri"/>
-              <a:buNone/>
-            </a:pPr>
-            <a:r>
-              <a:rPr sz="3000" b="1"/>
-              <a:t>Stack, rigour and honest limits</a:t>
-            </a:r>
-            <a:endParaRPr b="1">
-              <a:solidFill>
-                <a:srgbClr val="704EA6"/>
-              </a:solidFill>
-            </a:endParaRPr>
-          </a:p>
-        </p:txBody>
-      </p:sp>
-      <p:sp>
-        <p:nvSpPr>
-          <p:cNvPr id="126" name="Google Shape;126;p6"/>
-          <p:cNvSpPr txBox="1"/>
-          <p:nvPr>
-            <p:ph idx="1" type="body"/>
-          </p:nvPr>
-        </p:nvSpPr>
-        <p:spPr>
-          <a:xfrm>
-            <a:off x="822960" y="1463040"/>
-            <a:ext cx="9692640" cy="4480560"/>
-          </a:xfrm>
-          <a:prstGeom prst="rect">
-            <a:avLst/>
-          </a:prstGeom>
-          <a:noFill/>
-          <a:ln>
-            <a:noFill/>
-          </a:ln>
-        </p:spPr>
-        <p:txBody>
-          <a:bodyPr anchorCtr="0" anchor="t" bIns="45700" lIns="91425" spcFirstLastPara="1" rIns="91425" wrap="square" tIns="45700">
-            <a:normAutofit/>
-          </a:bodyPr>
-          <a:lstStyle/>
-          <a:p>
-            <a:pPr indent="-50800" lvl="0" marL="228600" rtl="0" algn="l">
-              <a:lnSpc>
-                <a:spcPct val="90000"/>
-              </a:lnSpc>
-              <a:spcBef>
-                <a:spcPts val="0"/>
-              </a:spcBef>
-              <a:spcAft>
-                <a:spcPts val="0"/>
-              </a:spcAft>
-              <a:buClr>
-                <a:schemeClr val="dk1"/>
-              </a:buClr>
-              <a:buSzPts val="2800"/>
-              <a:buNone/>
-            </a:pPr>
-            <a:r>
-              <a:rPr sz="2000" b="0"/>
-              <a:t>Stack: LiveKit Agents · Silero VAD · faster-whisper large-v3-turbo · Kokoro-82M · Gemini 3.6 Flash (hosted) · Python 3.11, Docker.</a:t>
-            </a:r>
-            <a:endParaRPr/>
-          </a:p>
-          <a:p>
-            <a:r>
-              <a:rPr sz="2000" b="0"/>
-              <a:t>635 deterministic tests (stepped clock, scripted model), TraceChecker on every run, adversarial explorer over 19 race scenarios.</a:t>
-            </a:r>
-          </a:p>
-          <a:p>
-            <a:r>
-              <a:rPr sz="2000" b="0"/>
-              <a:t>One-command reproduction: pinned FDB commit, sha256-checked data, weights baked into the image.</a:t>
-            </a:r>
-          </a:p>
-          <a:p>
-            <a:r>
-              <a:rPr sz="2000" b="0"/>
-              <a:t>Limits: Janus follows the published tool contract, not labels that disagree with it (e.g. an undeclared pets_allowed); housing 35%; the hosted model is not bit-reproducible; the extension's device backend is simulated.</a:t>
-            </a:r>
-          </a:p>
-        </p:txBody>
-      </p:sp>
-    </p:spTree>
-  </p:cSld>
-  <p:clrMapOvr>
-    <a:masterClrMapping/>
-  </p:clrMapOvr>
-</p:sld>
-</file>
-
-<file path=ppt/slides/slide7.xml><?xml version="1.0" encoding="utf-8"?>
-<p:sld xmlns:a="http://schemas.openxmlformats.org/drawingml/2006/main" xmlns:r="http://schemas.openxmlformats.org/officeDocument/2006/relationships" xmlns:mc="http://schemas.openxmlformats.org/markup-compatibility/2006" xmlns:mv="urn:schemas-microsoft-com:mac:vml" xmlns:p="http://schemas.openxmlformats.org/presentationml/2006/main" xmlns:c="http://schemas.openxmlformats.org/drawingml/2006/chart" xmlns:dgm="http://schemas.openxmlformats.org/drawingml/2006/diagram" xmlns:o="urn:schemas-microsoft-com:office:office" xmlns:v="urn:schemas-microsoft-com:vml" xmlns:pvml="urn:schemas-microsoft-com:office:powerpoint" xmlns:com="http://schemas.openxmlformats.org/drawingml/2006/compatibility" xmlns:p14="http://schemas.microsoft.com/office/powerpoint/2010/main" xmlns:p15="http://schemas.microsoft.com/office/powerpoint/2012/main" xmlns:ahyp="http://schemas.microsoft.com/office/drawing/2018/hyperlinkcolor">
-  <p:cSld>
-    <p:spTree>
-      <p:nvGrpSpPr>
-        <p:cNvPr id="130" name="Shape 130"/>
-        <p:cNvGrpSpPr/>
-        <p:nvPr/>
-      </p:nvGrpSpPr>
-      <p:grpSpPr>
-        <a:xfrm>
-          <a:off x="0" y="0"/>
-          <a:ext cx="0" cy="0"/>
-          <a:chOff x="0" y="0"/>
-          <a:chExt cx="0" cy="0"/>
-        </a:xfrm>
-      </p:grpSpPr>
-      <p:sp>
-        <p:nvSpPr>
-          <p:cNvPr id="131" name="Google Shape;131;p7"/>
-          <p:cNvSpPr txBox="1"/>
-          <p:nvPr>
-            <p:ph type="title"/>
-          </p:nvPr>
-        </p:nvSpPr>
-        <p:spPr>
-          <a:xfrm>
-            <a:off x="838200" y="320040"/>
-            <a:ext cx="10515600" cy="914400"/>
-          </a:xfrm>
-          <a:prstGeom prst="rect">
-            <a:avLst/>
-          </a:prstGeom>
-          <a:noFill/>
-          <a:ln>
-            <a:noFill/>
-          </a:ln>
-        </p:spPr>
-        <p:txBody>
-          <a:bodyPr anchorCtr="0" anchor="ctr" bIns="45700" lIns="91425" spcFirstLastPara="1" rIns="91425" wrap="square" tIns="45700">
-            <a:normAutofit/>
-          </a:bodyPr>
-          <a:lstStyle/>
-          <a:p>
-            <a:pPr indent="0" lvl="0" marL="0" rtl="0" algn="l">
-              <a:lnSpc>
-                <a:spcPct val="90000"/>
-              </a:lnSpc>
-              <a:spcBef>
-                <a:spcPts val="0"/>
-              </a:spcBef>
-              <a:spcAft>
-                <a:spcPts val="0"/>
-              </a:spcAft>
-              <a:buClr>
-                <a:srgbClr val="704EA6"/>
-              </a:buClr>
-              <a:buSzPts val="4400"/>
-              <a:buFont typeface="Calibri"/>
-              <a:buNone/>
-            </a:pPr>
-            <a:r>
-              <a:rPr sz="3000" b="1"/>
-              <a:t>Extension: Samsung-style home care</a:t>
-            </a:r>
-            <a:endParaRPr b="1">
-              <a:solidFill>
-                <a:srgbClr val="704EA6"/>
-              </a:solidFill>
-            </a:endParaRPr>
-          </a:p>
-        </p:txBody>
-      </p:sp>
-      <p:sp>
-        <p:nvSpPr>
-          <p:cNvPr id="132" name="Google Shape;132;p7"/>
-          <p:cNvSpPr txBox="1"/>
-          <p:nvPr>
-            <p:ph idx="1" type="body"/>
-          </p:nvPr>
-        </p:nvSpPr>
-        <p:spPr>
-          <a:xfrm>
-            <a:off x="7315200" y="1371600"/>
-            <a:ext cx="3566160" cy="4572000"/>
-          </a:xfrm>
-          <a:prstGeom prst="rect">
-            <a:avLst/>
-          </a:prstGeom>
-          <a:noFill/>
-          <a:ln>
-            <a:noFill/>
-          </a:ln>
-        </p:spPr>
-        <p:txBody>
-          <a:bodyPr anchorCtr="0" anchor="t" bIns="45700" lIns="91425" spcFirstLastPara="1" rIns="91425" wrap="square" tIns="45700">
-            <a:normAutofit/>
-          </a:bodyPr>
-          <a:lstStyle/>
-          <a:p>
-            <a:pPr indent="-50800" lvl="0" marL="228600" rtl="0" algn="l">
-              <a:lnSpc>
-                <a:spcPct val="90000"/>
-              </a:lnSpc>
-              <a:spcBef>
-                <a:spcPts val="0"/>
-              </a:spcBef>
-              <a:spcAft>
-                <a:spcPts val="0"/>
-              </a:spcAft>
-              <a:buClr>
-                <a:schemeClr val="dk1"/>
-              </a:buClr>
-              <a:buSzPts val="2800"/>
-              <a:buNone/>
-            </a:pPr>
-            <a:r>
-              <a:rPr sz="1400" b="0"/>
-              <a:t>Router read from the camera; a Samsung washer (codes 4C, 5C, UB, dC) through a SmartThings-shaped status.</a:t>
-            </a:r>
-            <a:endParaRPr/>
-          </a:p>
-          <a:p>
-            <a:r>
-              <a:rPr sz="1400" b="0"/>
-              <a:t>“Stop the wash … wait, just pause it”: the pending stop is never sent; pause and the booking go through once.</a:t>
-            </a:r>
-          </a:p>
-          <a:p>
-            <a:r>
-              <a:rPr sz="1400" b="0"/>
-              <a:t>“Resume” while 4C shows: the washer refuses, and the agent says so.</a:t>
-            </a:r>
-          </a:p>
-          <a:p>
-            <a:r>
-              <a:rPr sz="1400" b="0"/>
-              <a:t>Effect ledger per session: committed, withdrawn, refused, duplicates (0).</a:t>
-            </a:r>
-          </a:p>
-          <a:p>
-            <a:r>
-              <a:rPr sz="1400" b="0"/>
-              <a:t>Real: speech, camera, Gemini, the kernel. Simulated: the device and Samsung Care services.</a:t>
-            </a:r>
-          </a:p>
-        </p:txBody>
-      </p:sp>
-      <p:pic>
-        <p:nvPicPr>
-          <p:cNvPr id="133" name="Picture 132" descr="withdraw_one_of_two_writes.png"/>
-          <p:cNvPicPr>
-            <a:picLocks noChangeAspect="1"/>
-          </p:cNvPicPr>
-          <p:nvPr/>
-        </p:nvPicPr>
-        <p:blipFill>
-          <a:blip r:embed="rId3"/>
-          <a:stretch>
-            <a:fillRect/>
-          </a:stretch>
-        </p:blipFill>
-        <p:spPr>
-          <a:xfrm>
-            <a:off x="457200" y="1371600"/>
-            <a:ext cx="6675120" cy="4227576"/>
-          </a:xfrm>
-          <a:prstGeom prst="rect">
-            <a:avLst/>
-          </a:prstGeom>
-        </p:spPr>
-      </p:pic>
-    </p:spTree>
-  </p:cSld>
-  <p:clrMapOvr>
-    <a:masterClrMapping/>
-  </p:clrMapOvr>
-</p:sld>
-</file>
-
-<file path=ppt/slides/slide8.xml><?xml version="1.0" encoding="utf-8"?>
+<file path=ppt/slides/slide5.xml><?xml version="1.0" encoding="utf-8"?>
 <p:sld xmlns:a="http://schemas.openxmlformats.org/drawingml/2006/main" xmlns:r="http://schemas.openxmlformats.org/officeDocument/2006/relationships" xmlns:mc="http://schemas.openxmlformats.org/markup-compatibility/2006" xmlns:mv="urn:schemas-microsoft-com:mac:vml" xmlns:p="http://schemas.openxmlformats.org/presentationml/2006/main" xmlns:c="http://schemas.openxmlformats.org/drawingml/2006/chart" xmlns:dgm="http://schemas.openxmlformats.org/drawingml/2006/diagram" xmlns:o="urn:schemas-microsoft-com:office:office" xmlns:v="urn:schemas-microsoft-com:vml" xmlns:pvml="urn:schemas-microsoft-com:office:powerpoint" xmlns:com="http://schemas.openxmlformats.org/drawingml/2006/compatibility" xmlns:p14="http://schemas.microsoft.com/office/powerpoint/2010/main" xmlns:p15="http://schemas.microsoft.com/office/powerpoint/2012/main" xmlns:ahyp="http://schemas.microsoft.com/office/drawing/2018/hyperlinkcolor">
   <p:cSld>
     <p:spTree>
@@ -14860,7 +14530,337 @@
 </p:sld>
 </file>
 
-<file path=ppt/slides/slide9.xml><?xml version="1.0" encoding="utf-8"?>
+<file path=ppt/slides/slide6.xml><?xml version="1.0" encoding="utf-8"?>
+<p:sld xmlns:a="http://schemas.openxmlformats.org/drawingml/2006/main" xmlns:r="http://schemas.openxmlformats.org/officeDocument/2006/relationships" xmlns:mc="http://schemas.openxmlformats.org/markup-compatibility/2006" xmlns:mv="urn:schemas-microsoft-com:mac:vml" xmlns:p="http://schemas.openxmlformats.org/presentationml/2006/main" xmlns:c="http://schemas.openxmlformats.org/drawingml/2006/chart" xmlns:dgm="http://schemas.openxmlformats.org/drawingml/2006/diagram" xmlns:o="urn:schemas-microsoft-com:office:office" xmlns:v="urn:schemas-microsoft-com:vml" xmlns:pvml="urn:schemas-microsoft-com:office:powerpoint" xmlns:com="http://schemas.openxmlformats.org/drawingml/2006/compatibility" xmlns:p14="http://schemas.microsoft.com/office/powerpoint/2010/main" xmlns:p15="http://schemas.microsoft.com/office/powerpoint/2012/main" xmlns:ahyp="http://schemas.microsoft.com/office/drawing/2018/hyperlinkcolor">
+  <p:cSld>
+    <p:spTree>
+      <p:nvGrpSpPr>
+        <p:cNvPr id="130" name="Shape 130"/>
+        <p:cNvGrpSpPr/>
+        <p:nvPr/>
+      </p:nvGrpSpPr>
+      <p:grpSpPr>
+        <a:xfrm>
+          <a:off x="0" y="0"/>
+          <a:ext cx="0" cy="0"/>
+          <a:chOff x="0" y="0"/>
+          <a:chExt cx="0" cy="0"/>
+        </a:xfrm>
+      </p:grpSpPr>
+      <p:sp>
+        <p:nvSpPr>
+          <p:cNvPr id="131" name="Google Shape;131;p7"/>
+          <p:cNvSpPr txBox="1"/>
+          <p:nvPr>
+            <p:ph type="title"/>
+          </p:nvPr>
+        </p:nvSpPr>
+        <p:spPr>
+          <a:xfrm>
+            <a:off x="838200" y="320040"/>
+            <a:ext cx="10515600" cy="914400"/>
+          </a:xfrm>
+          <a:prstGeom prst="rect">
+            <a:avLst/>
+          </a:prstGeom>
+          <a:noFill/>
+          <a:ln>
+            <a:noFill/>
+          </a:ln>
+        </p:spPr>
+        <p:txBody>
+          <a:bodyPr anchorCtr="0" anchor="ctr" bIns="45700" lIns="91425" spcFirstLastPara="1" rIns="91425" wrap="square" tIns="45700">
+            <a:normAutofit/>
+          </a:bodyPr>
+          <a:lstStyle/>
+          <a:p>
+            <a:pPr indent="0" lvl="0" marL="0" rtl="0" algn="l">
+              <a:lnSpc>
+                <a:spcPct val="90000"/>
+              </a:lnSpc>
+              <a:spcBef>
+                <a:spcPts val="0"/>
+              </a:spcBef>
+              <a:spcAft>
+                <a:spcPts val="0"/>
+              </a:spcAft>
+              <a:buClr>
+                <a:srgbClr val="704EA6"/>
+              </a:buClr>
+              <a:buSzPts val="4400"/>
+              <a:buFont typeface="Calibri"/>
+              <a:buNone/>
+            </a:pPr>
+            <a:r>
+              <a:rPr sz="3000" b="1"/>
+              <a:t>Extension: Samsung-style home care</a:t>
+            </a:r>
+            <a:endParaRPr b="1">
+              <a:solidFill>
+                <a:srgbClr val="704EA6"/>
+              </a:solidFill>
+            </a:endParaRPr>
+          </a:p>
+        </p:txBody>
+      </p:sp>
+      <p:sp>
+        <p:nvSpPr>
+          <p:cNvPr id="132" name="Google Shape;132;p7"/>
+          <p:cNvSpPr txBox="1"/>
+          <p:nvPr>
+            <p:ph idx="1" type="body"/>
+          </p:nvPr>
+        </p:nvSpPr>
+        <p:spPr>
+          <a:xfrm>
+            <a:off x="7315200" y="1371600"/>
+            <a:ext cx="3566160" cy="4572000"/>
+          </a:xfrm>
+          <a:prstGeom prst="rect">
+            <a:avLst/>
+          </a:prstGeom>
+          <a:noFill/>
+          <a:ln>
+            <a:noFill/>
+          </a:ln>
+        </p:spPr>
+        <p:txBody>
+          <a:bodyPr anchorCtr="0" anchor="t" bIns="45700" lIns="91425" spcFirstLastPara="1" rIns="91425" wrap="square" tIns="45700">
+            <a:normAutofit/>
+          </a:bodyPr>
+          <a:lstStyle/>
+          <a:p>
+            <a:pPr indent="-50800" lvl="0" marL="228600" rtl="0" algn="l">
+              <a:lnSpc>
+                <a:spcPct val="90000"/>
+              </a:lnSpc>
+              <a:spcBef>
+                <a:spcPts val="0"/>
+              </a:spcBef>
+              <a:spcAft>
+                <a:spcPts val="0"/>
+              </a:spcAft>
+              <a:buClr>
+                <a:schemeClr val="dk1"/>
+              </a:buClr>
+              <a:buSzPts val="2800"/>
+              <a:buNone/>
+            </a:pPr>
+            <a:r>
+              <a:rPr sz="1400" b="0"/>
+              <a:t>Router read from the camera; a Samsung washer (codes 4C, 5C, UB, dC) through a SmartThings-shaped status.</a:t>
+            </a:r>
+            <a:endParaRPr/>
+          </a:p>
+          <a:p>
+            <a:r>
+              <a:rPr sz="1400" b="0"/>
+              <a:t>“Stop the wash … wait, just pause it”: the pending stop is never sent; pause and the booking go through once.</a:t>
+            </a:r>
+          </a:p>
+          <a:p>
+            <a:r>
+              <a:rPr sz="1400" b="0"/>
+              <a:t>“Resume” while 4C shows: the washer refuses, and the agent says so.</a:t>
+            </a:r>
+          </a:p>
+          <a:p>
+            <a:r>
+              <a:rPr sz="1400" b="0"/>
+              <a:t>Effect ledger per session: committed, withdrawn, refused, duplicates (0).</a:t>
+            </a:r>
+          </a:p>
+          <a:p>
+            <a:r>
+              <a:rPr sz="1400" b="0"/>
+              <a:t>Real: speech, camera, Gemini, the kernel. Simulated: the device and Samsung Care services.</a:t>
+            </a:r>
+          </a:p>
+        </p:txBody>
+      </p:sp>
+      <p:pic>
+        <p:nvPicPr>
+          <p:cNvPr id="133" name="Picture 132" descr="withdraw_one_of_two_writes.png"/>
+          <p:cNvPicPr>
+            <a:picLocks noChangeAspect="1"/>
+          </p:cNvPicPr>
+          <p:nvPr/>
+        </p:nvPicPr>
+        <p:blipFill>
+          <a:blip r:embed="rId3"/>
+          <a:stretch>
+            <a:fillRect/>
+          </a:stretch>
+        </p:blipFill>
+        <p:spPr>
+          <a:xfrm>
+            <a:off x="457200" y="1371600"/>
+            <a:ext cx="6675120" cy="4227576"/>
+          </a:xfrm>
+          <a:prstGeom prst="rect">
+            <a:avLst/>
+          </a:prstGeom>
+        </p:spPr>
+      </p:pic>
+    </p:spTree>
+  </p:cSld>
+  <p:clrMapOvr>
+    <a:masterClrMapping/>
+  </p:clrMapOvr>
+</p:sld>
+</file>
+
+<file path=ppt/slides/slide7.xml><?xml version="1.0" encoding="utf-8"?>
+<p:sld xmlns:a="http://schemas.openxmlformats.org/drawingml/2006/main" xmlns:r="http://schemas.openxmlformats.org/officeDocument/2006/relationships" xmlns:mc="http://schemas.openxmlformats.org/markup-compatibility/2006" xmlns:mv="urn:schemas-microsoft-com:mac:vml" xmlns:p="http://schemas.openxmlformats.org/presentationml/2006/main" xmlns:c="http://schemas.openxmlformats.org/drawingml/2006/chart" xmlns:dgm="http://schemas.openxmlformats.org/drawingml/2006/diagram" xmlns:o="urn:schemas-microsoft-com:office:office" xmlns:v="urn:schemas-microsoft-com:vml" xmlns:pvml="urn:schemas-microsoft-com:office:powerpoint" xmlns:com="http://schemas.openxmlformats.org/drawingml/2006/compatibility" xmlns:p14="http://schemas.microsoft.com/office/powerpoint/2010/main" xmlns:p15="http://schemas.microsoft.com/office/powerpoint/2012/main" xmlns:ahyp="http://schemas.microsoft.com/office/drawing/2018/hyperlinkcolor">
+  <p:cSld>
+    <p:spTree>
+      <p:nvGrpSpPr>
+        <p:cNvPr id="124" name="Shape 124"/>
+        <p:cNvGrpSpPr/>
+        <p:nvPr/>
+      </p:nvGrpSpPr>
+      <p:grpSpPr>
+        <a:xfrm>
+          <a:off x="0" y="0"/>
+          <a:ext cx="0" cy="0"/>
+          <a:chOff x="0" y="0"/>
+          <a:chExt cx="0" cy="0"/>
+        </a:xfrm>
+      </p:grpSpPr>
+      <p:sp>
+        <p:nvSpPr>
+          <p:cNvPr id="125" name="Google Shape;125;p6"/>
+          <p:cNvSpPr txBox="1"/>
+          <p:nvPr>
+            <p:ph type="title"/>
+          </p:nvPr>
+        </p:nvSpPr>
+        <p:spPr>
+          <a:xfrm>
+            <a:off x="838200" y="320040"/>
+            <a:ext cx="10515600" cy="914400"/>
+          </a:xfrm>
+          <a:prstGeom prst="rect">
+            <a:avLst/>
+          </a:prstGeom>
+          <a:noFill/>
+          <a:ln>
+            <a:noFill/>
+          </a:ln>
+        </p:spPr>
+        <p:txBody>
+          <a:bodyPr anchorCtr="0" anchor="ctr" bIns="45700" lIns="91425" spcFirstLastPara="1" rIns="91425" wrap="square" tIns="45700">
+            <a:normAutofit/>
+          </a:bodyPr>
+          <a:lstStyle/>
+          <a:p>
+            <a:pPr indent="0" lvl="0" marL="0" rtl="0" algn="l">
+              <a:lnSpc>
+                <a:spcPct val="90000"/>
+              </a:lnSpc>
+              <a:spcBef>
+                <a:spcPts val="0"/>
+              </a:spcBef>
+              <a:spcAft>
+                <a:spcPts val="0"/>
+              </a:spcAft>
+              <a:buClr>
+                <a:srgbClr val="704EA6"/>
+              </a:buClr>
+              <a:buSzPts val="4400"/>
+              <a:buFont typeface="Calibri"/>
+              <a:buNone/>
+            </a:pPr>
+            <a:r>
+              <a:rPr sz="3000" b="1"/>
+              <a:t>Stack, rigour and honest limits</a:t>
+            </a:r>
+            <a:endParaRPr b="1">
+              <a:solidFill>
+                <a:srgbClr val="704EA6"/>
+              </a:solidFill>
+            </a:endParaRPr>
+          </a:p>
+        </p:txBody>
+      </p:sp>
+      <p:sp>
+        <p:nvSpPr>
+          <p:cNvPr id="126" name="Google Shape;126;p6"/>
+          <p:cNvSpPr txBox="1"/>
+          <p:nvPr>
+            <p:ph idx="1" type="body"/>
+          </p:nvPr>
+        </p:nvSpPr>
+        <p:spPr>
+          <a:xfrm>
+            <a:off x="822960" y="1463040"/>
+            <a:ext cx="9692640" cy="4480560"/>
+          </a:xfrm>
+          <a:prstGeom prst="rect">
+            <a:avLst/>
+          </a:prstGeom>
+          <a:noFill/>
+          <a:ln>
+            <a:noFill/>
+          </a:ln>
+        </p:spPr>
+        <p:txBody>
+          <a:bodyPr anchorCtr="0" anchor="t" bIns="45700" lIns="91425" spcFirstLastPara="1" rIns="91425" wrap="square" tIns="45700">
+            <a:normAutofit/>
+          </a:bodyPr>
+          <a:lstStyle/>
+          <a:p>
+            <a:pPr indent="-50800" lvl="0" marL="228600" rtl="0" algn="l">
+              <a:lnSpc>
+                <a:spcPct val="90000"/>
+              </a:lnSpc>
+              <a:spcBef>
+                <a:spcPts val="0"/>
+              </a:spcBef>
+              <a:spcAft>
+                <a:spcPts val="0"/>
+              </a:spcAft>
+              <a:buClr>
+                <a:schemeClr val="dk1"/>
+              </a:buClr>
+              <a:buSzPts val="2800"/>
+              <a:buNone/>
+            </a:pPr>
+            <a:r>
+              <a:rPr sz="2000" b="0"/>
+              <a:t>Stack: LiveKit Agents · Silero VAD · faster-whisper large-v3-turbo · Kokoro-82M · Gemini 3.6 Flash (hosted) · Python 3.11, Docker.</a:t>
+            </a:r>
+            <a:endParaRPr/>
+          </a:p>
+          <a:p>
+            <a:r>
+              <a:rPr sz="2000" b="0"/>
+              <a:t>645 deterministic tests (stepped clock, scripted model), TraceChecker on every run, adversarial explorer over 19 race scenarios.</a:t>
+            </a:r>
+          </a:p>
+          <a:p>
+            <a:r>
+              <a:rPr sz="2000" b="0"/>
+              <a:t>One-command reproduction: pinned FDB commit, sha256-checked data, weights baked into the image.</a:t>
+            </a:r>
+          </a:p>
+          <a:p>
+            <a:r>
+              <a:rPr sz="2000" b="0"/>
+              <a:t>Limits: Janus follows the published tool contract, not labels that disagree with it (e.g. an undeclared pets_allowed); housing 35%; the hosted model is not bit-reproducible; the extension's device backend is simulated.</a:t>
+            </a:r>
+          </a:p>
+        </p:txBody>
+      </p:sp>
+    </p:spTree>
+  </p:cSld>
+  <p:clrMapOvr>
+    <a:masterClrMapping/>
+  </p:clrMapOvr>
+</p:sld>
+</file>
+
+<file path=ppt/slides/slide8.xml><?xml version="1.0" encoding="utf-8"?>
 <p:sld xmlns:a="http://schemas.openxmlformats.org/drawingml/2006/main" xmlns:r="http://schemas.openxmlformats.org/officeDocument/2006/relationships" xmlns:mc="http://schemas.openxmlformats.org/markup-compatibility/2006" xmlns:mv="urn:schemas-microsoft-com:mac:vml" xmlns:p="http://schemas.openxmlformats.org/presentationml/2006/main" xmlns:c="http://schemas.openxmlformats.org/drawingml/2006/chart" xmlns:dgm="http://schemas.openxmlformats.org/drawingml/2006/diagram" xmlns:o="urn:schemas-microsoft-com:office:office" xmlns:v="urn:schemas-microsoft-com:vml" xmlns:pvml="urn:schemas-microsoft-com:office:powerpoint" xmlns:com="http://schemas.openxmlformats.org/drawingml/2006/compatibility" xmlns:p14="http://schemas.microsoft.com/office/powerpoint/2010/main" xmlns:p15="http://schemas.microsoft.com/office/powerpoint/2012/main" xmlns:ahyp="http://schemas.microsoft.com/office/drawing/2018/hyperlinkcolor">
   <p:cSld>
     <p:spTree>

</xml_diff>